<commit_message>
docs(deck): update Presentation Deck with latest KOHLER_AI_Bathroom_Designer.pptx
</commit_message>
<xml_diff>
--- a/assets/Presentation Deck/KOHLER_AI_Bathroom_Designer.pptx
+++ b/assets/Presentation Deck/KOHLER_AI_Bathroom_Designer.pptx
@@ -356,7 +356,7 @@
           <a:p>
             <a:fld id="{5BCAD085-E8A6-8845-BD4E-CB4CCA059FC4}" type="datetimeFigureOut">
               <a:rPr lang="en-US" smtClean="0"/>
-              <a:t>9/19/2026</a:t>
+              <a:t>9/20/2026</a:t>
             </a:fld>
             <a:endParaRPr lang="en-US"/>
           </a:p>
@@ -564,7 +564,7 @@
           <a:p>
             <a:fld id="{5BCAD085-E8A6-8845-BD4E-CB4CCA059FC4}" type="datetimeFigureOut">
               <a:rPr lang="en-US" smtClean="0"/>
-              <a:t>9/19/2026</a:t>
+              <a:t>9/20/2026</a:t>
             </a:fld>
             <a:endParaRPr lang="en-US"/>
           </a:p>
@@ -822,7 +822,7 @@
           <a:p>
             <a:fld id="{5BCAD085-E8A6-8845-BD4E-CB4CCA059FC4}" type="datetimeFigureOut">
               <a:rPr lang="en-US" smtClean="0"/>
-              <a:t>9/19/2026</a:t>
+              <a:t>9/20/2026</a:t>
             </a:fld>
             <a:endParaRPr lang="en-US"/>
           </a:p>
@@ -992,7 +992,7 @@
           <a:p>
             <a:fld id="{5BCAD085-E8A6-8845-BD4E-CB4CCA059FC4}" type="datetimeFigureOut">
               <a:rPr lang="en-US" smtClean="0"/>
-              <a:t>9/19/2026</a:t>
+              <a:t>9/20/2026</a:t>
             </a:fld>
             <a:endParaRPr lang="en-US"/>
           </a:p>
@@ -1329,7 +1329,7 @@
           <a:p>
             <a:fld id="{5BCAD085-E8A6-8845-BD4E-CB4CCA059FC4}" type="datetimeFigureOut">
               <a:rPr lang="en-US" smtClean="0"/>
-              <a:t>9/19/2026</a:t>
+              <a:t>9/20/2026</a:t>
             </a:fld>
             <a:endParaRPr lang="en-US"/>
           </a:p>
@@ -1604,7 +1604,7 @@
           <a:p>
             <a:fld id="{5BCAD085-E8A6-8845-BD4E-CB4CCA059FC4}" type="datetimeFigureOut">
               <a:rPr lang="en-US" smtClean="0"/>
-              <a:t>9/19/2026</a:t>
+              <a:t>9/20/2026</a:t>
             </a:fld>
             <a:endParaRPr lang="en-US"/>
           </a:p>
@@ -1983,7 +1983,7 @@
           <a:p>
             <a:fld id="{5BCAD085-E8A6-8845-BD4E-CB4CCA059FC4}" type="datetimeFigureOut">
               <a:rPr lang="en-US" smtClean="0"/>
-              <a:t>9/19/2026</a:t>
+              <a:t>9/20/2026</a:t>
             </a:fld>
             <a:endParaRPr lang="en-US"/>
           </a:p>
@@ -2101,7 +2101,7 @@
           <a:p>
             <a:fld id="{5BCAD085-E8A6-8845-BD4E-CB4CCA059FC4}" type="datetimeFigureOut">
               <a:rPr lang="en-US" smtClean="0"/>
-              <a:t>9/19/2026</a:t>
+              <a:t>9/20/2026</a:t>
             </a:fld>
             <a:endParaRPr lang="en-US"/>
           </a:p>
@@ -2274,7 +2274,7 @@
           <a:p>
             <a:fld id="{5BCAD085-E8A6-8845-BD4E-CB4CCA059FC4}" type="datetimeFigureOut">
               <a:rPr lang="en-US" smtClean="0"/>
-              <a:t>9/19/2026</a:t>
+              <a:t>9/20/2026</a:t>
             </a:fld>
             <a:endParaRPr lang="en-US"/>
           </a:p>
@@ -2630,7 +2630,7 @@
           <a:p>
             <a:fld id="{5BCAD085-E8A6-8845-BD4E-CB4CCA059FC4}" type="datetimeFigureOut">
               <a:rPr lang="en-US" smtClean="0"/>
-              <a:t>9/19/2026</a:t>
+              <a:t>9/20/2026</a:t>
             </a:fld>
             <a:endParaRPr lang="en-US"/>
           </a:p>
@@ -3009,7 +3009,7 @@
           <a:p>
             <a:fld id="{5BCAD085-E8A6-8845-BD4E-CB4CCA059FC4}" type="datetimeFigureOut">
               <a:rPr lang="en-US" smtClean="0"/>
-              <a:t>9/19/2026</a:t>
+              <a:t>9/20/2026</a:t>
             </a:fld>
             <a:endParaRPr lang="en-US"/>
           </a:p>
@@ -3298,7 +3298,7 @@
           <a:p>
             <a:fld id="{5BCAD085-E8A6-8845-BD4E-CB4CCA059FC4}" type="datetimeFigureOut">
               <a:rPr lang="en-US" smtClean="0"/>
-              <a:t>9/19/2026</a:t>
+              <a:t>9/20/2026</a:t>
             </a:fld>
             <a:endParaRPr lang="en-US"/>
           </a:p>
@@ -4768,7 +4768,7 @@
         <p:spPr>
           <a:xfrm>
             <a:off x="6980996" y="2394123"/>
-            <a:ext cx="3977640" cy="3736920"/>
+            <a:ext cx="3977640" cy="3621504"/>
           </a:xfrm>
           <a:prstGeom prst="rect">
             <a:avLst/>
@@ -4818,32 +4818,32 @@
               <a:buChar char="Ø"/>
             </a:pPr>
             <a:r>
-              <a:rPr sz="1250" b="1" dirty="0">
-                <a:solidFill>
-                  <a:srgbClr val="FFFFFF"/>
-                </a:solidFill>
-                <a:latin typeface="Segoe UI"/>
-              </a:rPr>
-              <a:t>Predefined Constraints: </a:t>
-            </a:r>
-            <a:r>
-              <a:rPr sz="1250" dirty="0">
+              <a:rPr lang="en-US" sz="1200" b="1" dirty="0">
                 <a:solidFill>
                   <a:srgbClr val="DCE2EC"/>
                 </a:solidFill>
                 <a:latin typeface="Segoe UI"/>
               </a:rPr>
-              <a:t>Parametric envelope sliders (width, depth, height), budget dial, and curated themes.</a:t>
+              <a:t>Predefined Constraints &amp; Inclusions: </a:t>
+            </a:r>
+            <a:r>
+              <a:rPr lang="en-US" sz="1200" dirty="0">
+                <a:solidFill>
+                  <a:srgbClr val="DCE2EC"/>
+                </a:solidFill>
+                <a:latin typeface="Segoe UI"/>
+              </a:rPr>
+              <a:t>Parametric room envelope sliders, target budget dial, and interactive Fixture Inclusions (Toilet, Shower, Vanity, Mirror, Bathtub).</a:t>
             </a:r>
             <a:br>
-              <a:rPr lang="en-IN" sz="1250" dirty="0">
+              <a:rPr lang="en-IN" sz="1200" dirty="0">
                 <a:solidFill>
                   <a:srgbClr val="DCE2EC"/>
                 </a:solidFill>
                 <a:latin typeface="Segoe UI"/>
               </a:rPr>
             </a:br>
-            <a:endParaRPr sz="1250" dirty="0">
+            <a:endParaRPr sz="1200" dirty="0">
               <a:solidFill>
                 <a:srgbClr val="DCE2EC"/>
               </a:solidFill>
@@ -4859,7 +4859,7 @@
               <a:buChar char="Ø"/>
             </a:pPr>
             <a:r>
-              <a:rPr sz="1250" b="1" dirty="0">
+              <a:rPr sz="1200" b="1" dirty="0">
                 <a:solidFill>
                   <a:srgbClr val="FFFFFF"/>
                 </a:solidFill>
@@ -4868,7 +4868,7 @@
               <a:t>Natural-Language AI: </a:t>
             </a:r>
             <a:r>
-              <a:rPr sz="1250" dirty="0">
+              <a:rPr sz="1200" dirty="0">
                 <a:solidFill>
                   <a:srgbClr val="DCE2EC"/>
                 </a:solidFill>
@@ -4877,7 +4877,7 @@
               <a:t>Voice &amp; freeform prompt extraction supporting complex customer </a:t>
             </a:r>
             <a:r>
-              <a:rPr sz="1250" dirty="0" err="1">
+              <a:rPr sz="1200" dirty="0" err="1">
                 <a:solidFill>
                   <a:srgbClr val="DCE2EC"/>
                 </a:solidFill>
@@ -4886,7 +4886,7 @@
               <a:t>wishlists</a:t>
             </a:r>
             <a:r>
-              <a:rPr sz="1250" dirty="0">
+              <a:rPr sz="1200" dirty="0">
                 <a:solidFill>
                   <a:srgbClr val="DCE2EC"/>
                 </a:solidFill>
@@ -4895,14 +4895,14 @@
               <a:t> in real-time.</a:t>
             </a:r>
             <a:br>
-              <a:rPr lang="en-IN" sz="1250" dirty="0">
+              <a:rPr lang="en-IN" sz="1200" dirty="0">
                 <a:solidFill>
                   <a:srgbClr val="DCE2EC"/>
                 </a:solidFill>
                 <a:latin typeface="Segoe UI"/>
               </a:rPr>
             </a:br>
-            <a:endParaRPr sz="1250" dirty="0">
+            <a:endParaRPr sz="1200" dirty="0">
               <a:solidFill>
                 <a:srgbClr val="DCE2EC"/>
               </a:solidFill>
@@ -4918,7 +4918,7 @@
               <a:buChar char="Ø"/>
             </a:pPr>
             <a:r>
-              <a:rPr sz="1250" b="1" dirty="0">
+              <a:rPr sz="1200" b="1" dirty="0">
                 <a:solidFill>
                   <a:srgbClr val="FFFFFF"/>
                 </a:solidFill>
@@ -4927,7 +4927,7 @@
               <a:t>Pareto Scoring: </a:t>
             </a:r>
             <a:r>
-              <a:rPr sz="1250" dirty="0">
+              <a:rPr sz="1200" dirty="0">
                 <a:solidFill>
                   <a:srgbClr val="DCE2EC"/>
                 </a:solidFill>
@@ -4936,14 +4936,14 @@
               <a:t>Mathematical multi-objective optimization balancing physical clearance, budget, and aesthetics.</a:t>
             </a:r>
             <a:br>
-              <a:rPr lang="en-IN" sz="1250" dirty="0">
+              <a:rPr lang="en-IN" sz="1200" dirty="0">
                 <a:solidFill>
                   <a:srgbClr val="DCE2EC"/>
                 </a:solidFill>
                 <a:latin typeface="Segoe UI"/>
               </a:rPr>
             </a:br>
-            <a:endParaRPr sz="1250" dirty="0">
+            <a:endParaRPr sz="1200" dirty="0">
               <a:solidFill>
                 <a:srgbClr val="DCE2EC"/>
               </a:solidFill>
@@ -4959,7 +4959,7 @@
               <a:buChar char="Ø"/>
             </a:pPr>
             <a:r>
-              <a:rPr sz="1250" b="1" dirty="0">
+              <a:rPr sz="1200" b="1" dirty="0">
                 <a:solidFill>
                   <a:srgbClr val="FFFFFF"/>
                 </a:solidFill>
@@ -4968,7 +4968,7 @@
               <a:t>Production Speed: </a:t>
             </a:r>
             <a:r>
-              <a:rPr sz="1250" dirty="0">
+              <a:rPr sz="1200" dirty="0">
                 <a:solidFill>
                   <a:srgbClr val="DCE2EC"/>
                 </a:solidFill>
@@ -5339,7 +5339,7 @@
         <p:spPr>
           <a:xfrm>
             <a:off x="896112" y="2194560"/>
-            <a:ext cx="2185416" cy="3672800"/>
+            <a:ext cx="2185416" cy="3780522"/>
           </a:xfrm>
           <a:prstGeom prst="rect">
             <a:avLst/>
@@ -5389,7 +5389,7 @@
               <a:buChar char="•"/>
             </a:pPr>
             <a:r>
-              <a:rPr sz="1200" b="1" dirty="0">
+              <a:rPr lang="en-US" sz="1100" b="1" dirty="0">
                 <a:solidFill>
                   <a:srgbClr val="FFFFFF"/>
                 </a:solidFill>
@@ -5398,23 +5398,23 @@
               <a:t>Regex &amp; NLP Parser: </a:t>
             </a:r>
             <a:r>
-              <a:rPr sz="1200" dirty="0">
+              <a:rPr lang="en-US" sz="1100" dirty="0">
+                <a:solidFill>
+                  <a:srgbClr val="FFFFFF"/>
+                </a:solidFill>
+                <a:latin typeface="Segoe UI"/>
+              </a:rPr>
+              <a:t>Extracts dimensions (12x9 ft), budget ceilings, aesthetic theme, and fixture intent tokens (e.g. soaking tub, smart bidet, no shower).</a:t>
+            </a:r>
+            <a:br>
+              <a:rPr lang="en-IN" sz="1100" dirty="0">
                 <a:solidFill>
                   <a:srgbClr val="DCE2EC"/>
                 </a:solidFill>
                 <a:latin typeface="Segoe UI"/>
               </a:rPr>
-              <a:t>Extracts dimensions (12x9 ft), room category (Spa, Powder), and budget caps.</a:t>
-            </a:r>
-            <a:br>
-              <a:rPr lang="en-IN" sz="1200" dirty="0">
-                <a:solidFill>
-                  <a:srgbClr val="DCE2EC"/>
-                </a:solidFill>
-                <a:latin typeface="Segoe UI"/>
-              </a:rPr>
             </a:br>
-            <a:endParaRPr sz="1200" dirty="0">
+            <a:endParaRPr sz="1100" dirty="0">
               <a:solidFill>
                 <a:srgbClr val="DCE2EC"/>
               </a:solidFill>
@@ -5430,7 +5430,7 @@
               <a:buChar char="•"/>
             </a:pPr>
             <a:r>
-              <a:rPr sz="1200" b="1" dirty="0">
+              <a:rPr sz="1100" b="1" dirty="0">
                 <a:solidFill>
                   <a:srgbClr val="FFFFFF"/>
                 </a:solidFill>
@@ -5439,7 +5439,7 @@
               <a:t>Dynamic Badging: </a:t>
             </a:r>
             <a:r>
-              <a:rPr sz="1200" dirty="0">
+              <a:rPr sz="1100" dirty="0">
                 <a:solidFill>
                   <a:srgbClr val="DCE2EC"/>
                 </a:solidFill>
@@ -5448,14 +5448,14 @@
               <a:t>Visual feedback chips confirm extracted constraints before prompt execution.</a:t>
             </a:r>
             <a:br>
-              <a:rPr lang="en-IN" sz="1200" dirty="0">
+              <a:rPr lang="en-IN" sz="1100" dirty="0">
                 <a:solidFill>
                   <a:srgbClr val="DCE2EC"/>
                 </a:solidFill>
                 <a:latin typeface="Segoe UI"/>
               </a:rPr>
             </a:br>
-            <a:endParaRPr sz="1200" dirty="0">
+            <a:endParaRPr sz="1100" dirty="0">
               <a:solidFill>
                 <a:srgbClr val="DCE2EC"/>
               </a:solidFill>
@@ -5471,7 +5471,7 @@
               <a:buChar char="•"/>
             </a:pPr>
             <a:r>
-              <a:rPr sz="1200" b="1" dirty="0">
+              <a:rPr sz="1100" b="1" dirty="0">
                 <a:solidFill>
                   <a:srgbClr val="FFFFFF"/>
                 </a:solidFill>
@@ -5480,7 +5480,7 @@
               <a:t>Prompt Guard 22M: </a:t>
             </a:r>
             <a:r>
-              <a:rPr sz="1200" dirty="0">
+              <a:rPr sz="1100" dirty="0">
                 <a:solidFill>
                   <a:srgbClr val="DCE2EC"/>
                 </a:solidFill>
@@ -5489,7 +5489,7 @@
               <a:t>Meta Llama security model sanitizes prompt injection and jailbreak attempts on </a:t>
             </a:r>
             <a:r>
-              <a:rPr sz="1200" dirty="0" err="1">
+              <a:rPr sz="1100" dirty="0" err="1">
                 <a:solidFill>
                   <a:srgbClr val="DCE2EC"/>
                 </a:solidFill>
@@ -5498,7 +5498,7 @@
               <a:t>Groq</a:t>
             </a:r>
             <a:r>
-              <a:rPr sz="1200" dirty="0">
+              <a:rPr sz="1100" dirty="0">
                 <a:solidFill>
                   <a:srgbClr val="DCE2EC"/>
                 </a:solidFill>
@@ -5780,7 +5780,7 @@
         <p:spPr>
           <a:xfrm>
             <a:off x="6382512" y="2194560"/>
-            <a:ext cx="2185416" cy="3557384"/>
+            <a:ext cx="2185416" cy="3911327"/>
           </a:xfrm>
           <a:prstGeom prst="rect">
             <a:avLst/>
@@ -5907,22 +5907,22 @@
               <a:buChar char="•"/>
             </a:pPr>
             <a:r>
-              <a:rPr sz="1150" b="1" dirty="0">
-                <a:solidFill>
-                  <a:srgbClr val="FFFFFF"/>
-                </a:solidFill>
-                <a:latin typeface="Segoe UI"/>
-              </a:rPr>
-              <a:t>Clearance Checks: </a:t>
-            </a:r>
-            <a:r>
-              <a:rPr sz="1150" dirty="0">
+              <a:rPr lang="en-US" sz="1150" b="1" dirty="0">
                 <a:solidFill>
                   <a:srgbClr val="DCE2EC"/>
                 </a:solidFill>
                 <a:latin typeface="Segoe UI"/>
               </a:rPr>
-              <a:t>21" toilet front, 24" shower entry, 15" centerline clearances strictly evaluated.</a:t>
+              <a:t>Ergonomic Clearance Checks: </a:t>
+            </a:r>
+            <a:r>
+              <a:rPr lang="en-US" sz="1150" dirty="0">
+                <a:solidFill>
+                  <a:srgbClr val="DCE2EC"/>
+                </a:solidFill>
+                <a:latin typeface="Segoe UI"/>
+              </a:rPr>
+              <a:t>NKBA 21" toilet front, 15" side centerline, 24" shower entry, and 21" bathtub access perimeter strictly verified.</a:t>
             </a:r>
             <a:br>
               <a:rPr lang="en-IN" sz="1150" dirty="0">
@@ -7067,7 +7067,7 @@
         <p:spPr>
           <a:xfrm>
             <a:off x="914400" y="4343400"/>
-            <a:ext cx="4846320" cy="1844095"/>
+            <a:ext cx="5029200" cy="1856919"/>
           </a:xfrm>
           <a:prstGeom prst="rect">
             <a:avLst/>
@@ -7100,8 +7100,8 @@
               <a:t> - </a:t>
             </a:r>
             <a:r>
-              <a:rPr sz="1200" u="sng" dirty="0"/>
-              <a:t>16 Genuine Kohler Production Fixtures</a:t>
+              <a:rPr lang="en-US" sz="1200" u="sng" dirty="0"/>
+              <a:t>60 Genuine Kohler Production Fixtures Across 8 Categories</a:t>
             </a:r>
             <a:br>
               <a:rPr lang="en-IN" sz="1200" dirty="0"/>
@@ -7123,149 +7123,218 @@
               </a:defRPr>
             </a:pPr>
             <a:r>
-              <a:rPr sz="1200" b="1" dirty="0">
+              <a:rPr lang="en-US" sz="900" b="1" dirty="0">
                 <a:solidFill>
                   <a:srgbClr val="DCE2EC"/>
                 </a:solidFill>
                 <a:latin typeface="Segoe UI"/>
               </a:rPr>
-              <a:t> Smart &amp; 1-Piece Toilets:</a:t>
-            </a:r>
-            <a:r>
-              <a:rPr sz="1200" dirty="0">
-                <a:solidFill>
-                  <a:srgbClr val="A0A8B6"/>
-                </a:solidFill>
-                <a:latin typeface="Segoe UI"/>
-              </a:rPr>
-              <a:t> Veil™ (K-5401IN), Reach™ (K-3983IN-S), Ove™ (K-17688IN).</a:t>
+              <a:t>Toilets &amp; Bidets (12 SKUs): Veil™ Smart One-Piece (K-5401IN), Innate™, Reach™ Wall-Hung, Ove™, Leap™, </a:t>
+            </a:r>
+            <a:r>
+              <a:rPr lang="en-US" sz="900" b="1" dirty="0" err="1">
+                <a:solidFill>
+                  <a:srgbClr val="DCE2EC"/>
+                </a:solidFill>
+                <a:latin typeface="Segoe UI"/>
+              </a:rPr>
+              <a:t>Vive</a:t>
+            </a:r>
+            <a:r>
+              <a:rPr lang="en-US" sz="900" b="1" dirty="0">
+                <a:solidFill>
+                  <a:srgbClr val="DCE2EC"/>
+                </a:solidFill>
+                <a:latin typeface="Segoe UI"/>
+              </a:rPr>
+              <a:t>™.</a:t>
             </a:r>
           </a:p>
           <a:p>
             <a:pPr marL="171450" indent="-171450">
               <a:spcAft>
-                <a:spcPts val="300"/>
+                <a:spcPts val="200"/>
               </a:spcAft>
               <a:buFont typeface="Wingdings" panose="05000000000000000000" pitchFamily="2" charset="2"/>
               <a:buChar char="q"/>
+              <a:defRPr sz="850" b="1">
+                <a:solidFill>
+                  <a:srgbClr val="40C08A"/>
+                </a:solidFill>
+                <a:latin typeface="Segoe UI"/>
+              </a:defRPr>
             </a:pPr>
             <a:r>
-              <a:rPr sz="1200" b="1" dirty="0">
+              <a:rPr lang="en-US" sz="900" b="1" dirty="0">
                 <a:solidFill>
                   <a:srgbClr val="DCE2EC"/>
                 </a:solidFill>
                 <a:latin typeface="Segoe UI"/>
               </a:rPr>
-              <a:t>Integrated Vanities &amp; Basins:</a:t>
-            </a:r>
-            <a:r>
-              <a:rPr sz="1200" dirty="0">
-                <a:solidFill>
-                  <a:srgbClr val="A0A8B6"/>
-                </a:solidFill>
-                <a:latin typeface="Segoe UI"/>
-              </a:rPr>
-              <a:t> Trace™ (K-30375IN), </a:t>
-            </a:r>
-            <a:r>
-              <a:rPr sz="1200" dirty="0" err="1">
-                <a:solidFill>
-                  <a:srgbClr val="A0A8B6"/>
+              <a:t>Vanities &amp; Basins (12 SKUs): Trace™ (K-30375IN), </a:t>
+            </a:r>
+            <a:r>
+              <a:rPr lang="en-US" sz="900" b="1" dirty="0" err="1">
+                <a:solidFill>
+                  <a:srgbClr val="DCE2EC"/>
                 </a:solidFill>
                 <a:latin typeface="Segoe UI"/>
               </a:rPr>
               <a:t>Vive</a:t>
             </a:r>
             <a:r>
-              <a:rPr sz="1200" dirty="0">
-                <a:solidFill>
-                  <a:srgbClr val="A0A8B6"/>
+              <a:rPr lang="en-US" sz="900" b="1" dirty="0">
+                <a:solidFill>
+                  <a:srgbClr val="DCE2EC"/>
                 </a:solidFill>
                 <a:latin typeface="Segoe UI"/>
               </a:rPr>
               <a:t>™ (K-28782IN), </a:t>
             </a:r>
             <a:r>
-              <a:rPr sz="1200" dirty="0" err="1">
-                <a:solidFill>
-                  <a:srgbClr val="A0A8B6"/>
+              <a:rPr lang="en-US" sz="900" b="1" dirty="0" err="1">
+                <a:solidFill>
+                  <a:srgbClr val="DCE2EC"/>
                 </a:solidFill>
                 <a:latin typeface="Segoe UI"/>
               </a:rPr>
               <a:t>Brazn</a:t>
             </a:r>
             <a:r>
-              <a:rPr sz="1200" dirty="0">
-                <a:solidFill>
-                  <a:srgbClr val="A0A8B6"/>
-                </a:solidFill>
-                <a:latin typeface="Segoe UI"/>
-              </a:rPr>
-              <a:t>™ &amp; Forefront™.</a:t>
+              <a:rPr lang="en-US" sz="900" b="1" dirty="0">
+                <a:solidFill>
+                  <a:srgbClr val="DCE2EC"/>
+                </a:solidFill>
+                <a:latin typeface="Segoe UI"/>
+              </a:rPr>
+              <a:t>™ Vessel, Forefront™ Semi-Recessed.</a:t>
             </a:r>
           </a:p>
           <a:p>
             <a:pPr marL="171450" indent="-171450">
               <a:spcAft>
-                <a:spcPts val="300"/>
+                <a:spcPts val="200"/>
               </a:spcAft>
               <a:buFont typeface="Wingdings" panose="05000000000000000000" pitchFamily="2" charset="2"/>
               <a:buChar char="q"/>
+              <a:defRPr sz="850" b="1">
+                <a:solidFill>
+                  <a:srgbClr val="40C08A"/>
+                </a:solidFill>
+                <a:latin typeface="Segoe UI"/>
+              </a:defRPr>
             </a:pPr>
             <a:r>
-              <a:rPr sz="1200" b="1" dirty="0">
+              <a:rPr lang="en-US" sz="900" b="1" dirty="0">
                 <a:solidFill>
                   <a:srgbClr val="DCE2EC"/>
                 </a:solidFill>
                 <a:latin typeface="Segoe UI"/>
               </a:rPr>
-              <a:t>Showers &amp; Fittings:</a:t>
-            </a:r>
-            <a:r>
-              <a:rPr sz="1200" dirty="0">
-                <a:solidFill>
-                  <a:srgbClr val="A0A8B6"/>
-                </a:solidFill>
-                <a:latin typeface="Segoe UI"/>
-              </a:rPr>
-              <a:t> Statement™ </a:t>
-            </a:r>
-            <a:r>
-              <a:rPr sz="1200" dirty="0" err="1">
-                <a:solidFill>
-                  <a:srgbClr val="A0A8B6"/>
+              <a:t>Showers Subcategorized (11 SKUs): Statement™ </a:t>
+            </a:r>
+            <a:r>
+              <a:rPr lang="en-US" sz="900" b="1" dirty="0" err="1">
+                <a:solidFill>
+                  <a:srgbClr val="DCE2EC"/>
                 </a:solidFill>
                 <a:latin typeface="Segoe UI"/>
               </a:rPr>
               <a:t>Katalyst</a:t>
             </a:r>
             <a:r>
-              <a:rPr sz="1200" dirty="0">
-                <a:solidFill>
-                  <a:srgbClr val="A0A8B6"/>
-                </a:solidFill>
-                <a:latin typeface="Segoe UI"/>
-              </a:rPr>
-              <a:t>, </a:t>
-            </a:r>
-            <a:r>
-              <a:rPr sz="1200" dirty="0" err="1">
-                <a:solidFill>
-                  <a:srgbClr val="A0A8B6"/>
+              <a:rPr lang="en-US" sz="900" b="1" dirty="0">
+                <a:solidFill>
+                  <a:srgbClr val="DCE2EC"/>
+                </a:solidFill>
+                <a:latin typeface="Segoe UI"/>
+              </a:rPr>
+              <a:t> </a:t>
+            </a:r>
+            <a:r>
+              <a:rPr lang="en-US" sz="900" b="1" dirty="0" err="1">
+                <a:solidFill>
+                  <a:srgbClr val="DCE2EC"/>
+                </a:solidFill>
+                <a:latin typeface="Segoe UI"/>
+              </a:rPr>
+              <a:t>Rainhead</a:t>
+            </a:r>
+            <a:r>
+              <a:rPr lang="en-US" sz="900" b="1" dirty="0">
+                <a:solidFill>
+                  <a:srgbClr val="DCE2EC"/>
+                </a:solidFill>
+                <a:latin typeface="Segoe UI"/>
+              </a:rPr>
+              <a:t>, Elate™ &amp; Contra™ Sliding Enclosures, New Trilogy™ Pivot Doors.</a:t>
+            </a:r>
+          </a:p>
+          <a:p>
+            <a:pPr marL="171450" indent="-171450">
+              <a:spcAft>
+                <a:spcPts val="200"/>
+              </a:spcAft>
+              <a:buFont typeface="Wingdings" panose="05000000000000000000" pitchFamily="2" charset="2"/>
+              <a:buChar char="q"/>
+              <a:defRPr sz="850" b="1">
+                <a:solidFill>
+                  <a:srgbClr val="40C08A"/>
+                </a:solidFill>
+                <a:latin typeface="Segoe UI"/>
+              </a:defRPr>
+            </a:pPr>
+            <a:r>
+              <a:rPr lang="en-US" sz="900" b="1" dirty="0">
+                <a:solidFill>
+                  <a:srgbClr val="DCE2EC"/>
+                </a:solidFill>
+                <a:latin typeface="Segoe UI"/>
+              </a:rPr>
+              <a:t>Bathtubs, Faucets &amp; Smart Mirrors (25 SKUs): </a:t>
+            </a:r>
+            <a:r>
+              <a:rPr lang="en-US" sz="900" b="1" dirty="0" err="1">
+                <a:solidFill>
+                  <a:srgbClr val="DCE2EC"/>
                 </a:solidFill>
                 <a:latin typeface="Segoe UI"/>
               </a:rPr>
               <a:t>Evok</a:t>
             </a:r>
             <a:r>
-              <a:rPr sz="1200" dirty="0">
-                <a:solidFill>
-                  <a:srgbClr val="A0A8B6"/>
-                </a:solidFill>
-                <a:latin typeface="Segoe UI"/>
-              </a:rPr>
-              <a:t> 2.0™ bath, New Trilogy™, Purist™ &amp; Parallel™.</a:t>
-            </a:r>
+              <a:rPr lang="en-US" sz="900" b="1" dirty="0">
+                <a:solidFill>
+                  <a:srgbClr val="DCE2EC"/>
+                </a:solidFill>
+                <a:latin typeface="Segoe UI"/>
+              </a:rPr>
+              <a:t> 2.0™ Freestanding Acrylic Soaking &amp; Whirlpool Tubs, Purist™, Parallel™, </a:t>
+            </a:r>
+            <a:r>
+              <a:rPr lang="en-US" sz="900" b="1" dirty="0" err="1">
+                <a:solidFill>
+                  <a:srgbClr val="DCE2EC"/>
+                </a:solidFill>
+                <a:latin typeface="Segoe UI"/>
+              </a:rPr>
+              <a:t>Verdera</a:t>
+            </a:r>
+            <a:r>
+              <a:rPr lang="en-US" sz="900" b="1" dirty="0">
+                <a:solidFill>
+                  <a:srgbClr val="DCE2EC"/>
+                </a:solidFill>
+                <a:latin typeface="Segoe UI"/>
+              </a:rPr>
+              <a:t>™ Voice &amp; Ming™ LED Mirrors.</a:t>
+            </a:r>
+            <a:endParaRPr sz="900" dirty="0">
+              <a:solidFill>
+                <a:srgbClr val="A0A8B6"/>
+              </a:solidFill>
+              <a:latin typeface="Segoe UI"/>
+            </a:endParaRPr>
           </a:p>
         </p:txBody>
       </p:sp>

</xml_diff>